<commit_message>
Updated revised project presentation
</commit_message>
<xml_diff>
--- a/vba-sap-document-batch-export/Resources/Project_powerpoint_presentation.pptx
+++ b/vba-sap-document-batch-export/Resources/Project_powerpoint_presentation.pptx
@@ -15898,7 +15898,7 @@
             <a:tbl>
               <a:tblPr bandRow="1" firstRow="1">
                 <a:noFill/>
-                <a:tableStyleId>{86F4F23C-7E0D-42DB-8650-568553BAC35E}</a:tableStyleId>
+                <a:tableStyleId>{F6211C87-F546-4F43-882A-191325B19022}</a:tableStyleId>
               </a:tblPr>
               <a:tblGrid>
                 <a:gridCol w="1228725"/>
@@ -16921,7 +16921,7 @@
                 <a:cs typeface="Inter"/>
                 <a:sym typeface="Inter"/>
               </a:rPr>
-              <a:t>Improved consistency</a:t>
+              <a:t>Reduced Manual Effort </a:t>
             </a:r>
             <a:r>
               <a:rPr b="1" i="0" lang="en-US" sz="1275" u="none" cap="none" strike="noStrike">
@@ -21294,7 +21294,7 @@
         <p:spPr>
           <a:xfrm>
             <a:off x="1104900" y="4217640"/>
-            <a:ext cx="4776900" cy="471000"/>
+            <a:ext cx="4776900" cy="1043700"/>
           </a:xfrm>
           <a:prstGeom prst="rect">
             <a:avLst/>
@@ -21323,6 +21323,18 @@
               <a:buNone/>
             </a:pPr>
             <a:r>
+              <a:rPr b="1" lang="en-US" sz="1200">
+                <a:solidFill>
+                  <a:srgbClr val="FFFFFF"/>
+                </a:solidFill>
+                <a:latin typeface="Inter"/>
+                <a:ea typeface="Inter"/>
+                <a:cs typeface="Inter"/>
+                <a:sym typeface="Inter"/>
+              </a:rPr>
+              <a:t>Solution</a:t>
+            </a:r>
+            <a:r>
               <a:rPr b="1" i="0" lang="en-US" sz="1200" u="none" cap="none" strike="noStrike">
                 <a:solidFill>
                   <a:srgbClr val="FFFFFF"/>
@@ -21332,7 +21344,7 @@
                 <a:cs typeface="Inter"/>
                 <a:sym typeface="Inter"/>
               </a:rPr>
-              <a:t>Asynchronous Bypass:</a:t>
+              <a:t>:</a:t>
             </a:r>
             <a:r>
               <a:rPr b="0" i="0" lang="en-US" sz="1200" u="none" cap="none" strike="noStrike">
@@ -21344,7 +21356,19 @@
                 <a:cs typeface="Inter"/>
                 <a:sym typeface="Inter"/>
               </a:rPr>
-              <a:t> Launched a parallel background watcher thread to monitor native save dialog interfaces asynchronously.</a:t>
+              <a:t> </a:t>
+            </a:r>
+            <a:r>
+              <a:rPr lang="en-US" sz="1200">
+                <a:solidFill>
+                  <a:srgbClr val="CDD6F4"/>
+                </a:solidFill>
+                <a:latin typeface="Inter"/>
+                <a:ea typeface="Inter"/>
+                <a:cs typeface="Inter"/>
+                <a:sym typeface="Inter"/>
+              </a:rPr>
+              <a:t>Implemented an asynchronous background watcher that detects the Windows OLE "Server Busy" dialog triggered by extended SAP processing delays and dismisses it automatically so execution can continue.</a:t>
             </a:r>
             <a:endParaRPr/>
           </a:p>
@@ -21358,7 +21382,7 @@
         </p:nvSpPr>
         <p:spPr>
           <a:xfrm>
-            <a:off x="1104900" y="4804320"/>
+            <a:off x="1104900" y="5346709"/>
             <a:ext cx="4776900" cy="757200"/>
           </a:xfrm>
           <a:prstGeom prst="rect">
@@ -21511,7 +21535,7 @@
         </p:blipFill>
         <p:spPr>
           <a:xfrm>
-            <a:off x="771525" y="4828133"/>
+            <a:off x="771525" y="5370522"/>
             <a:ext cx="190500" cy="180975"/>
           </a:xfrm>
           <a:prstGeom prst="rect">
@@ -21690,7 +21714,7 @@
         </p:blipFill>
         <p:spPr>
           <a:xfrm>
-            <a:off x="6160275" y="1314450"/>
+            <a:off x="6160275" y="1939576"/>
             <a:ext cx="5410200" cy="2114550"/>
           </a:xfrm>
           <a:prstGeom prst="rect">
@@ -21718,7 +21742,7 @@
         </p:blipFill>
         <p:spPr>
           <a:xfrm>
-            <a:off x="6336613" y="4037525"/>
+            <a:off x="6336613" y="4662651"/>
             <a:ext cx="3114675" cy="1257300"/>
           </a:xfrm>
           <a:prstGeom prst="rect">
@@ -21738,7 +21762,7 @@
         </p:nvSpPr>
         <p:spPr>
           <a:xfrm>
-            <a:off x="9451300" y="3125625"/>
+            <a:off x="9451300" y="3750751"/>
             <a:ext cx="1947900" cy="1883400"/>
           </a:xfrm>
           <a:prstGeom prst="bentUpArrow">

</xml_diff>